<commit_message>
Redesign project 12 (smart-building-energy) deck off the panel layout it shared with Uday's delivered deck; now on unique topline layout
</commit_message>
<xml_diff>
--- a/ppt/smart-building-energy.pptx
+++ b/ppt/smart-building-energy.pptx
@@ -3318,60 +3318,14 @@
       <p:grpSpPr/>
       <p:sp>
         <p:nvSpPr>
-          <p:cNvPr id="4" name="Rounded Rectangle 3"/>
+          <p:cNvPr id="4" name="Rectangle 3"/>
           <p:cNvSpPr/>
           <p:nvPr/>
         </p:nvSpPr>
         <p:spPr>
           <a:xfrm>
-            <a:off x="502920" y="457200"/>
-            <a:ext cx="11183112" cy="5943600"/>
-          </a:xfrm>
-          <a:prstGeom prst="roundRect">
-            <a:avLst/>
-          </a:prstGeom>
-          <a:solidFill>
-            <a:srgbClr val="E9EFEB"/>
-          </a:solidFill>
-          <a:ln w="15240">
-            <a:solidFill>
-              <a:srgbClr val="4A7C59"/>
-            </a:solidFill>
-          </a:ln>
-          <a:effectLst/>
-        </p:spPr>
-        <p:style>
-          <a:lnRef idx="1">
-            <a:schemeClr val="accent1"/>
-          </a:lnRef>
-          <a:fillRef idx="3">
-            <a:schemeClr val="accent1"/>
-          </a:fillRef>
-          <a:effectRef idx="2">
-            <a:schemeClr val="accent1"/>
-          </a:effectRef>
-          <a:fontRef idx="minor">
-            <a:schemeClr val="lt1"/>
-          </a:fontRef>
-        </p:style>
-        <p:txBody>
-          <a:bodyPr rtlCol="0" anchor="ctr"/>
-          <a:lstStyle/>
-          <a:p>
-            <a:pPr algn="ctr"/>
-          </a:p>
-        </p:txBody>
-      </p:sp>
-      <p:sp>
-        <p:nvSpPr>
-          <p:cNvPr id="5" name="Rectangle 4"/>
-          <p:cNvSpPr/>
-          <p:nvPr/>
-        </p:nvSpPr>
-        <p:spPr>
-          <a:xfrm>
-            <a:off x="502920" y="457200"/>
-            <a:ext cx="11183112" cy="640080"/>
+            <a:off x="-91440" y="0"/>
+            <a:ext cx="12435840" cy="146304"/>
           </a:xfrm>
           <a:prstGeom prst="rect">
             <a:avLst/>
@@ -3418,19 +3372,19 @@
         </p:nvSpPr>
         <p:spPr>
           <a:xfrm>
-            <a:off x="822960" y="457200"/>
-            <a:ext cx="10515600" cy="640080"/>
+            <a:off x="640080" y="457200"/>
+            <a:ext cx="10972800" cy="868680"/>
           </a:xfrm>
         </p:spPr>
         <p:txBody>
-          <a:bodyPr wrap="square" anchor="ctr"/>
+          <a:bodyPr wrap="square" anchor="t"/>
           <a:lstStyle/>
           <a:p>
             <a:pPr algn="l"/>
             <a:r>
-              <a:rPr b="1" sz="2200">
-                <a:solidFill>
-                  <a:srgbClr val="FFFFFF"/>
+              <a:rPr b="1" sz="2700">
+                <a:solidFill>
+                  <a:srgbClr val="4A7C59"/>
                 </a:solidFill>
                 <a:latin typeface="Georgia"/>
               </a:rPr>
@@ -3451,8 +3405,8 @@
         </p:nvSpPr>
         <p:spPr>
           <a:xfrm>
-            <a:off x="960120" y="1371600"/>
-            <a:ext cx="10241280" cy="4754880"/>
+            <a:off x="658368" y="1508760"/>
+            <a:ext cx="10972800" cy="4754880"/>
           </a:xfrm>
         </p:spPr>
         <p:txBody>
@@ -3610,60 +3564,14 @@
       <p:grpSpPr/>
       <p:sp>
         <p:nvSpPr>
-          <p:cNvPr id="4" name="Rounded Rectangle 3"/>
+          <p:cNvPr id="4" name="Rectangle 3"/>
           <p:cNvSpPr/>
           <p:nvPr/>
         </p:nvSpPr>
         <p:spPr>
           <a:xfrm>
-            <a:off x="502920" y="457200"/>
-            <a:ext cx="11183112" cy="5943600"/>
-          </a:xfrm>
-          <a:prstGeom prst="roundRect">
-            <a:avLst/>
-          </a:prstGeom>
-          <a:solidFill>
-            <a:srgbClr val="E9EFEB"/>
-          </a:solidFill>
-          <a:ln w="15240">
-            <a:solidFill>
-              <a:srgbClr val="4A7C59"/>
-            </a:solidFill>
-          </a:ln>
-          <a:effectLst/>
-        </p:spPr>
-        <p:style>
-          <a:lnRef idx="1">
-            <a:schemeClr val="accent1"/>
-          </a:lnRef>
-          <a:fillRef idx="3">
-            <a:schemeClr val="accent1"/>
-          </a:fillRef>
-          <a:effectRef idx="2">
-            <a:schemeClr val="accent1"/>
-          </a:effectRef>
-          <a:fontRef idx="minor">
-            <a:schemeClr val="lt1"/>
-          </a:fontRef>
-        </p:style>
-        <p:txBody>
-          <a:bodyPr rtlCol="0" anchor="ctr"/>
-          <a:lstStyle/>
-          <a:p>
-            <a:pPr algn="ctr"/>
-          </a:p>
-        </p:txBody>
-      </p:sp>
-      <p:sp>
-        <p:nvSpPr>
-          <p:cNvPr id="5" name="Rectangle 4"/>
-          <p:cNvSpPr/>
-          <p:nvPr/>
-        </p:nvSpPr>
-        <p:spPr>
-          <a:xfrm>
-            <a:off x="502920" y="457200"/>
-            <a:ext cx="11183112" cy="640080"/>
+            <a:off x="-91440" y="0"/>
+            <a:ext cx="12435840" cy="146304"/>
           </a:xfrm>
           <a:prstGeom prst="rect">
             <a:avLst/>
@@ -3710,19 +3618,19 @@
         </p:nvSpPr>
         <p:spPr>
           <a:xfrm>
-            <a:off x="822960" y="457200"/>
-            <a:ext cx="10515600" cy="640080"/>
+            <a:off x="640080" y="457200"/>
+            <a:ext cx="10972800" cy="868680"/>
           </a:xfrm>
         </p:spPr>
         <p:txBody>
-          <a:bodyPr wrap="square" anchor="ctr"/>
+          <a:bodyPr wrap="square" anchor="t"/>
           <a:lstStyle/>
           <a:p>
             <a:pPr algn="l"/>
             <a:r>
-              <a:rPr b="1" sz="2200">
-                <a:solidFill>
-                  <a:srgbClr val="FFFFFF"/>
+              <a:rPr b="1" sz="2700">
+                <a:solidFill>
+                  <a:srgbClr val="4A7C59"/>
                 </a:solidFill>
                 <a:latin typeface="Georgia"/>
               </a:rPr>
@@ -3743,8 +3651,8 @@
         </p:nvSpPr>
         <p:spPr>
           <a:xfrm>
-            <a:off x="960120" y="1371600"/>
-            <a:ext cx="10241280" cy="4754880"/>
+            <a:off x="658368" y="1508760"/>
+            <a:ext cx="10972800" cy="4754880"/>
           </a:xfrm>
         </p:spPr>
         <p:txBody>
@@ -3934,60 +3842,14 @@
       <p:grpSpPr/>
       <p:sp>
         <p:nvSpPr>
-          <p:cNvPr id="4" name="Rounded Rectangle 3"/>
+          <p:cNvPr id="4" name="Rectangle 3"/>
           <p:cNvSpPr/>
           <p:nvPr/>
         </p:nvSpPr>
         <p:spPr>
           <a:xfrm>
-            <a:off x="502920" y="457200"/>
-            <a:ext cx="11183112" cy="5943600"/>
-          </a:xfrm>
-          <a:prstGeom prst="roundRect">
-            <a:avLst/>
-          </a:prstGeom>
-          <a:solidFill>
-            <a:srgbClr val="E9EFEB"/>
-          </a:solidFill>
-          <a:ln w="15240">
-            <a:solidFill>
-              <a:srgbClr val="4A7C59"/>
-            </a:solidFill>
-          </a:ln>
-          <a:effectLst/>
-        </p:spPr>
-        <p:style>
-          <a:lnRef idx="1">
-            <a:schemeClr val="accent1"/>
-          </a:lnRef>
-          <a:fillRef idx="3">
-            <a:schemeClr val="accent1"/>
-          </a:fillRef>
-          <a:effectRef idx="2">
-            <a:schemeClr val="accent1"/>
-          </a:effectRef>
-          <a:fontRef idx="minor">
-            <a:schemeClr val="lt1"/>
-          </a:fontRef>
-        </p:style>
-        <p:txBody>
-          <a:bodyPr rtlCol="0" anchor="ctr"/>
-          <a:lstStyle/>
-          <a:p>
-            <a:pPr algn="ctr"/>
-          </a:p>
-        </p:txBody>
-      </p:sp>
-      <p:sp>
-        <p:nvSpPr>
-          <p:cNvPr id="5" name="Rectangle 4"/>
-          <p:cNvSpPr/>
-          <p:nvPr/>
-        </p:nvSpPr>
-        <p:spPr>
-          <a:xfrm>
-            <a:off x="502920" y="457200"/>
-            <a:ext cx="11183112" cy="640080"/>
+            <a:off x="-91440" y="0"/>
+            <a:ext cx="12435840" cy="146304"/>
           </a:xfrm>
           <a:prstGeom prst="rect">
             <a:avLst/>
@@ -4034,19 +3896,19 @@
         </p:nvSpPr>
         <p:spPr>
           <a:xfrm>
-            <a:off x="822960" y="457200"/>
-            <a:ext cx="10515600" cy="640080"/>
+            <a:off x="640080" y="457200"/>
+            <a:ext cx="10972800" cy="868680"/>
           </a:xfrm>
         </p:spPr>
         <p:txBody>
-          <a:bodyPr wrap="square" anchor="ctr"/>
+          <a:bodyPr wrap="square" anchor="t"/>
           <a:lstStyle/>
           <a:p>
             <a:pPr algn="l"/>
             <a:r>
-              <a:rPr b="1" sz="2200">
-                <a:solidFill>
-                  <a:srgbClr val="FFFFFF"/>
+              <a:rPr b="1" sz="2700">
+                <a:solidFill>
+                  <a:srgbClr val="4A7C59"/>
                 </a:solidFill>
                 <a:latin typeface="Georgia"/>
               </a:rPr>
@@ -4067,8 +3929,8 @@
         </p:nvSpPr>
         <p:spPr>
           <a:xfrm>
-            <a:off x="960120" y="1371600"/>
-            <a:ext cx="5394960" cy="4754880"/>
+            <a:off x="658368" y="1508760"/>
+            <a:ext cx="5760720" cy="4663440"/>
           </a:xfrm>
         </p:spPr>
         <p:txBody>
@@ -4144,7 +4006,7 @@
       </p:sp>
       <p:pic>
         <p:nvPicPr>
-          <p:cNvPr id="6" name="Picture 5" descr="dashboard-desktop.png"/>
+          <p:cNvPr id="5" name="Picture 4" descr="dashboard-desktop.png"/>
           <p:cNvPicPr>
             <a:picLocks noChangeAspect="1"/>
           </p:cNvPicPr>
@@ -4158,7 +4020,7 @@
         </p:blipFill>
         <p:spPr>
           <a:xfrm>
-            <a:off x="6858769" y="1463040"/>
+            <a:off x="7178809" y="1554480"/>
             <a:ext cx="4021821" cy="4480560"/>
           </a:xfrm>
           <a:prstGeom prst="rect">
@@ -4186,60 +4048,14 @@
       <p:grpSpPr/>
       <p:sp>
         <p:nvSpPr>
-          <p:cNvPr id="4" name="Rounded Rectangle 3"/>
+          <p:cNvPr id="4" name="Rectangle 3"/>
           <p:cNvSpPr/>
           <p:nvPr/>
         </p:nvSpPr>
         <p:spPr>
           <a:xfrm>
-            <a:off x="502920" y="457200"/>
-            <a:ext cx="11183112" cy="5943600"/>
-          </a:xfrm>
-          <a:prstGeom prst="roundRect">
-            <a:avLst/>
-          </a:prstGeom>
-          <a:solidFill>
-            <a:srgbClr val="E9EFEB"/>
-          </a:solidFill>
-          <a:ln w="15240">
-            <a:solidFill>
-              <a:srgbClr val="4A7C59"/>
-            </a:solidFill>
-          </a:ln>
-          <a:effectLst/>
-        </p:spPr>
-        <p:style>
-          <a:lnRef idx="1">
-            <a:schemeClr val="accent1"/>
-          </a:lnRef>
-          <a:fillRef idx="3">
-            <a:schemeClr val="accent1"/>
-          </a:fillRef>
-          <a:effectRef idx="2">
-            <a:schemeClr val="accent1"/>
-          </a:effectRef>
-          <a:fontRef idx="minor">
-            <a:schemeClr val="lt1"/>
-          </a:fontRef>
-        </p:style>
-        <p:txBody>
-          <a:bodyPr rtlCol="0" anchor="ctr"/>
-          <a:lstStyle/>
-          <a:p>
-            <a:pPr algn="ctr"/>
-          </a:p>
-        </p:txBody>
-      </p:sp>
-      <p:sp>
-        <p:nvSpPr>
-          <p:cNvPr id="5" name="Rectangle 4"/>
-          <p:cNvSpPr/>
-          <p:nvPr/>
-        </p:nvSpPr>
-        <p:spPr>
-          <a:xfrm>
-            <a:off x="502920" y="457200"/>
-            <a:ext cx="11183112" cy="640080"/>
+            <a:off x="-91440" y="0"/>
+            <a:ext cx="12435840" cy="146304"/>
           </a:xfrm>
           <a:prstGeom prst="rect">
             <a:avLst/>
@@ -4286,19 +4102,19 @@
         </p:nvSpPr>
         <p:spPr>
           <a:xfrm>
-            <a:off x="822960" y="457200"/>
-            <a:ext cx="10515600" cy="640080"/>
+            <a:off x="640080" y="457200"/>
+            <a:ext cx="10972800" cy="868680"/>
           </a:xfrm>
         </p:spPr>
         <p:txBody>
-          <a:bodyPr wrap="square" anchor="ctr"/>
+          <a:bodyPr wrap="square" anchor="t"/>
           <a:lstStyle/>
           <a:p>
             <a:pPr algn="l"/>
             <a:r>
-              <a:rPr b="1" sz="2200">
-                <a:solidFill>
-                  <a:srgbClr val="FFFFFF"/>
+              <a:rPr b="1" sz="2700">
+                <a:solidFill>
+                  <a:srgbClr val="4A7C59"/>
                 </a:solidFill>
                 <a:latin typeface="Georgia"/>
               </a:rPr>
@@ -4319,8 +4135,8 @@
         </p:nvSpPr>
         <p:spPr>
           <a:xfrm>
-            <a:off x="960120" y="1371600"/>
-            <a:ext cx="10241280" cy="4754880"/>
+            <a:off x="658368" y="1508760"/>
+            <a:ext cx="10972800" cy="4754880"/>
           </a:xfrm>
         </p:spPr>
         <p:txBody>
@@ -4478,60 +4294,14 @@
       <p:grpSpPr/>
       <p:sp>
         <p:nvSpPr>
-          <p:cNvPr id="4" name="Rounded Rectangle 3"/>
+          <p:cNvPr id="4" name="Rectangle 3"/>
           <p:cNvSpPr/>
           <p:nvPr/>
         </p:nvSpPr>
         <p:spPr>
           <a:xfrm>
-            <a:off x="502920" y="457200"/>
-            <a:ext cx="11183112" cy="5943600"/>
-          </a:xfrm>
-          <a:prstGeom prst="roundRect">
-            <a:avLst/>
-          </a:prstGeom>
-          <a:solidFill>
-            <a:srgbClr val="E9EFEB"/>
-          </a:solidFill>
-          <a:ln w="15240">
-            <a:solidFill>
-              <a:srgbClr val="4A7C59"/>
-            </a:solidFill>
-          </a:ln>
-          <a:effectLst/>
-        </p:spPr>
-        <p:style>
-          <a:lnRef idx="1">
-            <a:schemeClr val="accent1"/>
-          </a:lnRef>
-          <a:fillRef idx="3">
-            <a:schemeClr val="accent1"/>
-          </a:fillRef>
-          <a:effectRef idx="2">
-            <a:schemeClr val="accent1"/>
-          </a:effectRef>
-          <a:fontRef idx="minor">
-            <a:schemeClr val="lt1"/>
-          </a:fontRef>
-        </p:style>
-        <p:txBody>
-          <a:bodyPr rtlCol="0" anchor="ctr"/>
-          <a:lstStyle/>
-          <a:p>
-            <a:pPr algn="ctr"/>
-          </a:p>
-        </p:txBody>
-      </p:sp>
-      <p:sp>
-        <p:nvSpPr>
-          <p:cNvPr id="5" name="Rectangle 4"/>
-          <p:cNvSpPr/>
-          <p:nvPr/>
-        </p:nvSpPr>
-        <p:spPr>
-          <a:xfrm>
-            <a:off x="502920" y="457200"/>
-            <a:ext cx="11183112" cy="640080"/>
+            <a:off x="-91440" y="0"/>
+            <a:ext cx="12435840" cy="146304"/>
           </a:xfrm>
           <a:prstGeom prst="rect">
             <a:avLst/>
@@ -4578,19 +4348,19 @@
         </p:nvSpPr>
         <p:spPr>
           <a:xfrm>
-            <a:off x="822960" y="457200"/>
-            <a:ext cx="10515600" cy="640080"/>
+            <a:off x="640080" y="457200"/>
+            <a:ext cx="10972800" cy="868680"/>
           </a:xfrm>
         </p:spPr>
         <p:txBody>
-          <a:bodyPr wrap="square" anchor="ctr"/>
+          <a:bodyPr wrap="square" anchor="t"/>
           <a:lstStyle/>
           <a:p>
             <a:pPr algn="l"/>
             <a:r>
-              <a:rPr b="1" sz="2200">
-                <a:solidFill>
-                  <a:srgbClr val="FFFFFF"/>
+              <a:rPr b="1" sz="2700">
+                <a:solidFill>
+                  <a:srgbClr val="4A7C59"/>
                 </a:solidFill>
                 <a:latin typeface="Georgia"/>
               </a:rPr>
@@ -4611,8 +4381,8 @@
         </p:nvSpPr>
         <p:spPr>
           <a:xfrm>
-            <a:off x="960120" y="1371600"/>
-            <a:ext cx="10241280" cy="4754880"/>
+            <a:off x="658368" y="1508760"/>
+            <a:ext cx="10972800" cy="4754880"/>
           </a:xfrm>
         </p:spPr>
         <p:txBody>

</xml_diff>